<commit_message>
Weekly deck: fill the empty space on the nine-changes slide
Co-Authored-By: Claude Opus 5.5 <noreply@anthropic.com>
Claude-Session: https://claude.ai/code/session_0125kNUJSvGZTKpq5m35Ucid
</commit_message>
<xml_diff>
--- a/Weekly_Report_Hybrid_DiL_Lab.pptx
+++ b/Weekly_Report_Hybrid_DiL_Lab.pptx
@@ -23675,7 +23675,7 @@
         <p:spPr>
           <a:xfrm>
             <a:off x="640080" y="2194560"/>
-            <a:ext cx="5166360" cy="2423160"/>
+            <a:ext cx="5166360" cy="2148840"/>
           </a:xfrm>
           <a:prstGeom prst="roundRect">
             <a:avLst/>
@@ -23718,8 +23718,8 @@
         </p:nvSpPr>
         <p:spPr>
           <a:xfrm>
-            <a:off x="822960" y="2304288"/>
-            <a:ext cx="4846320" cy="2286000"/>
+            <a:off x="822960" y="2331720"/>
+            <a:ext cx="4846320" cy="2011680"/>
           </a:xfrm>
           <a:prstGeom prst="rect">
             <a:avLst/>
@@ -23734,11 +23734,11 @@
           <a:p>
             <a:pPr algn="l">
               <a:spcAft>
-                <a:spcPts val="1400"/>
+                <a:spcPts val="1600"/>
               </a:spcAft>
             </a:pPr>
             <a:r>
-              <a:rPr sz="1600" b="1">
+              <a:rPr sz="1800" b="1">
                 <a:solidFill>
                   <a:srgbClr val="1E1E1E"/>
                 </a:solidFill>
@@ -23747,7 +23747,7 @@
               <a:t>1. Strip convolutions </a:t>
             </a:r>
             <a:r>
-              <a:rPr sz="1600" b="0">
+              <a:rPr sz="1800" b="0">
                 <a:solidFill>
                   <a:srgbClr val="1E1E1E"/>
                 </a:solidFill>
@@ -23759,11 +23759,11 @@
           <a:p>
             <a:pPr algn="l">
               <a:spcAft>
-                <a:spcPts val="1400"/>
+                <a:spcPts val="1600"/>
               </a:spcAft>
             </a:pPr>
             <a:r>
-              <a:rPr sz="1600" b="1">
+              <a:rPr sz="1800" b="1">
                 <a:solidFill>
                   <a:srgbClr val="1E1E1E"/>
                 </a:solidFill>
@@ -23772,7 +23772,7 @@
               <a:t>2. Residual shortcuts </a:t>
             </a:r>
             <a:r>
-              <a:rPr sz="1600" b="0">
+              <a:rPr sz="1800" b="0">
                 <a:solidFill>
                   <a:srgbClr val="1E1E1E"/>
                 </a:solidFill>
@@ -23784,11 +23784,11 @@
           <a:p>
             <a:pPr algn="l">
               <a:spcAft>
-                <a:spcPts val="1400"/>
+                <a:spcPts val="1600"/>
               </a:spcAft>
             </a:pPr>
             <a:r>
-              <a:rPr sz="1600" b="1">
+              <a:rPr sz="1800" b="1">
                 <a:solidFill>
                   <a:srgbClr val="1E1E1E"/>
                 </a:solidFill>
@@ -23797,7 +23797,7 @@
               <a:t>3. Channel attention (ECA) </a:t>
             </a:r>
             <a:r>
-              <a:rPr sz="1600" b="0">
+              <a:rPr sz="1800" b="0">
                 <a:solidFill>
                   <a:srgbClr val="1E1E1E"/>
                 </a:solidFill>
@@ -23898,7 +23898,7 @@
         <p:spPr>
           <a:xfrm>
             <a:off x="6172200" y="2194560"/>
-            <a:ext cx="5349240" cy="3794760"/>
+            <a:ext cx="5349240" cy="3703320"/>
           </a:xfrm>
           <a:prstGeom prst="roundRect">
             <a:avLst/>
@@ -23957,11 +23957,11 @@
           <a:p>
             <a:pPr algn="l">
               <a:spcAft>
-                <a:spcPts val="1000"/>
+                <a:spcPts val="1400"/>
               </a:spcAft>
             </a:pPr>
             <a:r>
-              <a:rPr sz="1600" b="1">
+              <a:rPr sz="1800" b="1">
                 <a:solidFill>
                   <a:srgbClr val="1E1E1E"/>
                 </a:solidFill>
@@ -23970,7 +23970,7 @@
               <a:t>4. GroupNorm </a:t>
             </a:r>
             <a:r>
-              <a:rPr sz="1600" b="0">
+              <a:rPr sz="1800" b="0">
                 <a:solidFill>
                   <a:srgbClr val="1E1E1E"/>
                 </a:solidFill>
@@ -23982,11 +23982,11 @@
           <a:p>
             <a:pPr algn="l">
               <a:spcAft>
-                <a:spcPts val="1000"/>
+                <a:spcPts val="1400"/>
               </a:spcAft>
             </a:pPr>
             <a:r>
-              <a:rPr sz="1600" b="1">
+              <a:rPr sz="1800" b="1">
                 <a:solidFill>
                   <a:srgbClr val="1E1E1E"/>
                 </a:solidFill>
@@ -23995,7 +23995,7 @@
               <a:t>5. No ReLU on the output </a:t>
             </a:r>
             <a:r>
-              <a:rPr sz="1600" b="0">
+              <a:rPr sz="1800" b="0">
                 <a:solidFill>
                   <a:srgbClr val="1E1E1E"/>
                 </a:solidFill>
@@ -24007,11 +24007,11 @@
           <a:p>
             <a:pPr algn="l">
               <a:spcAft>
-                <a:spcPts val="1000"/>
+                <a:spcPts val="1400"/>
               </a:spcAft>
             </a:pPr>
             <a:r>
-              <a:rPr sz="1600" b="1">
+              <a:rPr sz="1800" b="1">
                 <a:solidFill>
                   <a:srgbClr val="1E1E1E"/>
                 </a:solidFill>
@@ -24020,7 +24020,7 @@
               <a:t>6. Dice loss </a:t>
             </a:r>
             <a:r>
-              <a:rPr sz="1600" b="0">
+              <a:rPr sz="1800" b="0">
                 <a:solidFill>
                   <a:srgbClr val="1E1E1E"/>
                 </a:solidFill>
@@ -24032,11 +24032,11 @@
           <a:p>
             <a:pPr algn="l">
               <a:spcAft>
-                <a:spcPts val="1000"/>
+                <a:spcPts val="1400"/>
               </a:spcAft>
             </a:pPr>
             <a:r>
-              <a:rPr sz="1600" b="1">
+              <a:rPr sz="1800" b="1">
                 <a:solidFill>
                   <a:srgbClr val="1E1E1E"/>
                 </a:solidFill>
@@ -24045,7 +24045,7 @@
               <a:t>7. Same padding </a:t>
             </a:r>
             <a:r>
-              <a:rPr sz="1600" b="0">
+              <a:rPr sz="1800" b="0">
                 <a:solidFill>
                   <a:srgbClr val="1E1E1E"/>
                 </a:solidFill>
@@ -24057,11 +24057,11 @@
           <a:p>
             <a:pPr algn="l">
               <a:spcAft>
-                <a:spcPts val="1000"/>
+                <a:spcPts val="1400"/>
               </a:spcAft>
             </a:pPr>
             <a:r>
-              <a:rPr sz="1600" b="1">
+              <a:rPr sz="1800" b="1">
                 <a:solidFill>
                   <a:srgbClr val="1E1E1E"/>
                 </a:solidFill>
@@ -24070,7 +24070,7 @@
               <a:t>8. No class weighting </a:t>
             </a:r>
             <a:r>
-              <a:rPr sz="1600" b="0">
+              <a:rPr sz="1800" b="0">
                 <a:solidFill>
                   <a:srgbClr val="1E1E1E"/>
                 </a:solidFill>
@@ -24082,11 +24082,11 @@
           <a:p>
             <a:pPr algn="l">
               <a:spcAft>
-                <a:spcPts val="1000"/>
+                <a:spcPts val="1400"/>
               </a:spcAft>
             </a:pPr>
             <a:r>
-              <a:rPr sz="1600" b="1">
+              <a:rPr sz="1800" b="1">
                 <a:solidFill>
                   <a:srgbClr val="1E1E1E"/>
                 </a:solidFill>
@@ -24095,7 +24095,7 @@
               <a:t>9. New size &amp; training </a:t>
             </a:r>
             <a:r>
-              <a:rPr sz="1600" b="0">
+              <a:rPr sz="1800" b="0">
                 <a:solidFill>
                   <a:srgbClr val="1E1E1E"/>
                 </a:solidFill>
@@ -24108,14 +24108,58 @@
       </p:sp>
       <p:sp>
         <p:nvSpPr>
-          <p:cNvPr id="11" name="TextBox 10"/>
+          <p:cNvPr id="11" name="Rounded Rectangle 10"/>
+          <p:cNvSpPr/>
+          <p:nvPr/>
+        </p:nvSpPr>
+        <p:spPr>
+          <a:xfrm>
+            <a:off x="640080" y="4526280"/>
+            <a:ext cx="5166360" cy="1371600"/>
+          </a:xfrm>
+          <a:prstGeom prst="roundRect">
+            <a:avLst/>
+          </a:prstGeom>
+          <a:solidFill>
+            <a:srgbClr val="F6F7F9"/>
+          </a:solidFill>
+          <a:ln w="12700">
+            <a:solidFill>
+              <a:srgbClr val="D9DDE4"/>
+            </a:solidFill>
+          </a:ln>
+          <a:effectLst/>
+        </p:spPr>
+        <p:style>
+          <a:lnRef idx="1">
+            <a:schemeClr val="accent1"/>
+          </a:lnRef>
+          <a:fillRef idx="3">
+            <a:schemeClr val="accent1"/>
+          </a:fillRef>
+          <a:effectRef idx="2">
+            <a:schemeClr val="accent1"/>
+          </a:effectRef>
+          <a:fontRef idx="minor">
+            <a:schemeClr val="lt1"/>
+          </a:fontRef>
+        </p:style>
+        <p:txBody>
+          <a:bodyPr rtlCol="0" anchor="ctr"/>
+          <a:lstStyle/>
+          <a:p/>
+        </p:txBody>
+      </p:sp>
+      <p:sp>
+        <p:nvSpPr>
+          <p:cNvPr id="12" name="TextBox 11"/>
           <p:cNvSpPr txBox="1"/>
           <p:nvPr/>
         </p:nvSpPr>
         <p:spPr>
           <a:xfrm>
-            <a:off x="640080" y="4800600"/>
-            <a:ext cx="5166360" cy="1188720"/>
+            <a:off x="822960" y="4617720"/>
+            <a:ext cx="4846320" cy="1188720"/>
           </a:xfrm>
           <a:prstGeom prst="rect">
             <a:avLst/>
@@ -24123,7 +24167,7 @@
           <a:noFill/>
         </p:spPr>
         <p:txBody>
-          <a:bodyPr wrap="square" anchor="t" lIns="36576" rIns="36576" tIns="18288" bIns="18288">
+          <a:bodyPr wrap="square" anchor="ctr" lIns="36576" rIns="36576" tIns="18288" bIns="18288">
             <a:spAutoFit/>
           </a:bodyPr>
           <a:lstStyle/>
@@ -24134,7 +24178,7 @@
               </a:spcAft>
             </a:pPr>
             <a:r>
-              <a:rPr sz="1600" b="1">
+              <a:rPr sz="1800" b="1">
                 <a:solidFill>
                   <a:srgbClr val="1E1E1E"/>
                 </a:solidFill>
@@ -24143,7 +24187,7 @@
               <a:t>Result: </a:t>
             </a:r>
             <a:r>
-              <a:rPr sz="1600" b="0">
+              <a:rPr sz="1800" b="0">
                 <a:solidFill>
                   <a:srgbClr val="1E1E1E"/>
                 </a:solidFill>
@@ -24152,7 +24196,7 @@
               <a:t>max F1 </a:t>
             </a:r>
             <a:r>
-              <a:rPr sz="1600" b="1">
+              <a:rPr sz="1800" b="1">
                 <a:solidFill>
                   <a:srgbClr val="E31837"/>
                 </a:solidFill>
@@ -24161,7 +24205,7 @@
               <a:t>0.660 ± 0.004</a:t>
             </a:r>
             <a:r>
-              <a:rPr sz="1600" b="0">
+              <a:rPr sz="1800" b="0">
                 <a:solidFill>
                   <a:srgbClr val="1E1E1E"/>
                 </a:solidFill>

</xml_diff>

<commit_message>
Weekly deck: correct strip, class-weight, size and standings claims
- strips cover a KxK square (measured), picture and text fixed
- change 8: tf_unet has no class weighting either
- change 9: shrinks 4 times instead of 2; tf_unet max-pools twice
- 22% more parameters (not 18%); GroupNorm 'inside every block'
- standings: add RFDL 0.639 and Swin-UNETR 0.640; note +-0.04 uncertainty
- context doc: PART 21.1 '3 max-pools' corrected, 24.1 updated

Co-Authored-By: Claude Opus 5.5 <noreply@anthropic.com>
Claude-Session: https://claude.ai/code/session_0125kNUJSvGZTKpq5m35Ucid
</commit_message>
<xml_diff>
--- a/Weekly_Report_Hybrid_DiL_Lab.pptx
+++ b/Weekly_Report_Hybrid_DiL_Lab.pptx
@@ -21659,10 +21659,10 @@
         </p:nvGrpSpPr>
         <p:grpSpPr>
           <a:xfrm>
-            <a:off x="777239" y="2007656"/>
-            <a:ext cx="10607041" cy="3670767"/>
-            <a:chOff x="777239" y="2007656"/>
-            <a:chExt cx="10607041" cy="3670767"/>
+            <a:off x="777240" y="2007656"/>
+            <a:ext cx="10607040" cy="3670767"/>
+            <a:chOff x="777240" y="2007656"/>
+            <a:chExt cx="10607040" cy="3670767"/>
           </a:xfrm>
         </p:grpSpPr>
         <p:cxnSp>
@@ -21708,8 +21708,8 @@
           </p:nvSpPr>
           <p:spPr>
             <a:xfrm>
-              <a:off x="1095451" y="3367064"/>
-              <a:ext cx="878869" cy="1689567"/>
+              <a:off x="1024737" y="3367064"/>
+              <a:ext cx="683564" cy="1689567"/>
             </a:xfrm>
             <a:prstGeom prst="rect">
               <a:avLst/>
@@ -21750,8 +21750,8 @@
           </p:nvSpPr>
           <p:spPr>
             <a:xfrm>
-              <a:off x="777239" y="3037880"/>
-              <a:ext cx="1515291" cy="292608"/>
+              <a:off x="777240" y="3037880"/>
+              <a:ext cx="1178559" cy="292608"/>
             </a:xfrm>
             <a:prstGeom prst="rect">
               <a:avLst/>
@@ -21770,7 +21770,7 @@
                 </a:spcAft>
               </a:pPr>
               <a:r>
-                <a:rPr sz="1400" b="1">
+                <a:rPr sz="1300" b="1">
                   <a:solidFill>
                     <a:srgbClr val="1E1E1E"/>
                   </a:solidFill>
@@ -21789,8 +21789,8 @@
           </p:nvSpPr>
           <p:spPr>
             <a:xfrm>
-              <a:off x="777239" y="5111495"/>
-              <a:ext cx="1515291" cy="566928"/>
+              <a:off x="777240" y="5111495"/>
+              <a:ext cx="1178559" cy="566928"/>
             </a:xfrm>
             <a:prstGeom prst="rect">
               <a:avLst/>
@@ -21844,8 +21844,8 @@
           </p:nvSpPr>
           <p:spPr>
             <a:xfrm>
-              <a:off x="2610742" y="2798380"/>
-              <a:ext cx="878869" cy="2258251"/>
+              <a:off x="2203297" y="2798380"/>
+              <a:ext cx="683564" cy="2258251"/>
             </a:xfrm>
             <a:prstGeom prst="rect">
               <a:avLst/>
@@ -21886,8 +21886,8 @@
           </p:nvSpPr>
           <p:spPr>
             <a:xfrm>
-              <a:off x="2292531" y="2469196"/>
-              <a:ext cx="1515291" cy="292608"/>
+              <a:off x="1955800" y="2469196"/>
+              <a:ext cx="1178559" cy="292608"/>
             </a:xfrm>
             <a:prstGeom prst="rect">
               <a:avLst/>
@@ -21906,7 +21906,7 @@
                 </a:spcAft>
               </a:pPr>
               <a:r>
-                <a:rPr sz="1400" b="1">
+                <a:rPr sz="1300" b="1">
                   <a:solidFill>
                     <a:srgbClr val="1E1E1E"/>
                   </a:solidFill>
@@ -21925,8 +21925,8 @@
           </p:nvSpPr>
           <p:spPr>
             <a:xfrm>
-              <a:off x="2292531" y="5111495"/>
-              <a:ext cx="1515291" cy="566928"/>
+              <a:off x="1955800" y="5111495"/>
+              <a:ext cx="1178559" cy="566928"/>
             </a:xfrm>
             <a:prstGeom prst="rect">
               <a:avLst/>
@@ -21980,8 +21980,8 @@
           </p:nvSpPr>
           <p:spPr>
             <a:xfrm>
-              <a:off x="4126034" y="2707721"/>
-              <a:ext cx="878869" cy="2348910"/>
+              <a:off x="3381857" y="2707721"/>
+              <a:ext cx="683564" cy="2348910"/>
             </a:xfrm>
             <a:prstGeom prst="rect">
               <a:avLst/>
@@ -22022,8 +22022,8 @@
           </p:nvSpPr>
           <p:spPr>
             <a:xfrm>
-              <a:off x="3807822" y="2378537"/>
-              <a:ext cx="1515291" cy="292608"/>
+              <a:off x="3134360" y="2378537"/>
+              <a:ext cx="1178559" cy="292608"/>
             </a:xfrm>
             <a:prstGeom prst="rect">
               <a:avLst/>
@@ -22042,7 +22042,7 @@
                 </a:spcAft>
               </a:pPr>
               <a:r>
-                <a:rPr sz="1400" b="1">
+                <a:rPr sz="1300" b="1">
                   <a:solidFill>
                     <a:srgbClr val="1E1E1E"/>
                   </a:solidFill>
@@ -22061,8 +22061,8 @@
           </p:nvSpPr>
           <p:spPr>
             <a:xfrm>
-              <a:off x="3807822" y="5111495"/>
-              <a:ext cx="1515291" cy="566928"/>
+              <a:off x="3134360" y="5111495"/>
+              <a:ext cx="1178559" cy="566928"/>
             </a:xfrm>
             <a:prstGeom prst="rect">
               <a:avLst/>
@@ -22100,8 +22100,8 @@
           </p:nvSpPr>
           <p:spPr>
             <a:xfrm>
-              <a:off x="5641325" y="2633545"/>
-              <a:ext cx="878869" cy="2423086"/>
+              <a:off x="4560417" y="2633545"/>
+              <a:ext cx="683564" cy="2423086"/>
             </a:xfrm>
             <a:prstGeom prst="rect">
               <a:avLst/>
@@ -22142,8 +22142,8 @@
           </p:nvSpPr>
           <p:spPr>
             <a:xfrm>
-              <a:off x="5323114" y="2304361"/>
-              <a:ext cx="1515291" cy="292608"/>
+              <a:off x="4312920" y="2304361"/>
+              <a:ext cx="1178559" cy="292608"/>
             </a:xfrm>
             <a:prstGeom prst="rect">
               <a:avLst/>
@@ -22162,7 +22162,7 @@
                 </a:spcAft>
               </a:pPr>
               <a:r>
-                <a:rPr sz="1400" b="1">
+                <a:rPr sz="1300" b="1">
                   <a:solidFill>
                     <a:srgbClr val="1E1E1E"/>
                   </a:solidFill>
@@ -22181,8 +22181,8 @@
           </p:nvSpPr>
           <p:spPr>
             <a:xfrm>
-              <a:off x="5323114" y="5111495"/>
-              <a:ext cx="1515291" cy="566928"/>
+              <a:off x="4312920" y="5111495"/>
+              <a:ext cx="1178559" cy="566928"/>
             </a:xfrm>
             <a:prstGeom prst="rect">
               <a:avLst/>
@@ -22236,8 +22236,8 @@
           </p:nvSpPr>
           <p:spPr>
             <a:xfrm>
-              <a:off x="7156616" y="2592336"/>
-              <a:ext cx="878869" cy="2464295"/>
+              <a:off x="5738977" y="2592336"/>
+              <a:ext cx="683564" cy="2464295"/>
             </a:xfrm>
             <a:prstGeom prst="rect">
               <a:avLst/>
@@ -22278,8 +22278,8 @@
           </p:nvSpPr>
           <p:spPr>
             <a:xfrm>
-              <a:off x="6838405" y="2263152"/>
-              <a:ext cx="1515291" cy="292608"/>
+              <a:off x="5491479" y="2263152"/>
+              <a:ext cx="1178559" cy="292608"/>
             </a:xfrm>
             <a:prstGeom prst="rect">
               <a:avLst/>
@@ -22298,7 +22298,7 @@
                 </a:spcAft>
               </a:pPr>
               <a:r>
-                <a:rPr sz="1400" b="1">
+                <a:rPr sz="1300" b="1">
                   <a:solidFill>
                     <a:srgbClr val="1E1E1E"/>
                   </a:solidFill>
@@ -22317,8 +22317,8 @@
           </p:nvSpPr>
           <p:spPr>
             <a:xfrm>
-              <a:off x="6838405" y="5111495"/>
-              <a:ext cx="1515291" cy="566928"/>
+              <a:off x="5491479" y="5111495"/>
+              <a:ext cx="1178559" cy="566928"/>
             </a:xfrm>
             <a:prstGeom prst="rect">
               <a:avLst/>
@@ -22356,14 +22356,14 @@
           </p:nvSpPr>
           <p:spPr>
             <a:xfrm>
-              <a:off x="8671908" y="2345082"/>
-              <a:ext cx="878869" cy="2711549"/>
+              <a:off x="6917537" y="2423379"/>
+              <a:ext cx="683564" cy="2633252"/>
             </a:xfrm>
             <a:prstGeom prst="rect">
               <a:avLst/>
             </a:prstGeom>
             <a:solidFill>
-              <a:srgbClr val="E31837"/>
+              <a:srgbClr val="8E9AAF"/>
             </a:solidFill>
             <a:ln>
               <a:noFill/>
@@ -22398,8 +22398,8 @@
           </p:nvSpPr>
           <p:spPr>
             <a:xfrm>
-              <a:off x="8353697" y="2015898"/>
-              <a:ext cx="1515291" cy="292608"/>
+              <a:off x="6670040" y="2094195"/>
+              <a:ext cx="1178559" cy="292608"/>
             </a:xfrm>
             <a:prstGeom prst="rect">
               <a:avLst/>
@@ -22418,7 +22418,279 @@
                 </a:spcAft>
               </a:pPr>
               <a:r>
-                <a:rPr sz="1400" b="1">
+                <a:rPr sz="1300" b="1">
+                  <a:solidFill>
+                    <a:srgbClr val="1E1E1E"/>
+                  </a:solidFill>
+                  <a:latin typeface="Calibri"/>
+                </a:rPr>
+                <a:t>0.639</a:t>
+              </a:r>
+            </a:p>
+          </p:txBody>
+        </p:sp>
+        <p:sp>
+          <p:nvSpPr>
+            <p:cNvPr id="22" name="TextBox 21"/>
+            <p:cNvSpPr txBox="1"/>
+            <p:nvPr/>
+          </p:nvSpPr>
+          <p:spPr>
+            <a:xfrm>
+              <a:off x="6670040" y="5111495"/>
+              <a:ext cx="1178559" cy="566928"/>
+            </a:xfrm>
+            <a:prstGeom prst="rect">
+              <a:avLst/>
+            </a:prstGeom>
+            <a:noFill/>
+          </p:spPr>
+          <p:txBody>
+            <a:bodyPr wrap="square" anchor="t" lIns="36576" rIns="36576" tIns="18288" bIns="18288">
+              <a:spAutoFit/>
+            </a:bodyPr>
+            <a:lstStyle/>
+            <a:p>
+              <a:pPr algn="ctr">
+                <a:spcAft>
+                  <a:spcPts val="0"/>
+                </a:spcAft>
+              </a:pPr>
+              <a:r>
+                <a:rPr sz="1200" b="0">
+                  <a:solidFill>
+                    <a:srgbClr val="1E1E1E"/>
+                  </a:solidFill>
+                  <a:latin typeface="Calibri"/>
+                </a:rPr>
+                <a:t>RFDL</a:t>
+              </a:r>
+            </a:p>
+            <a:p>
+              <a:pPr algn="ctr">
+                <a:spcAft>
+                  <a:spcPts val="0"/>
+                </a:spcAft>
+              </a:pPr>
+              <a:r>
+                <a:rPr sz="1200" b="0">
+                  <a:solidFill>
+                    <a:srgbClr val="1E1E1E"/>
+                  </a:solidFill>
+                  <a:latin typeface="Calibri"/>
+                </a:rPr>
+                <a:t>(2024)</a:t>
+              </a:r>
+            </a:p>
+          </p:txBody>
+        </p:sp>
+        <p:sp>
+          <p:nvSpPr>
+            <p:cNvPr id="23" name="Rectangle 22"/>
+            <p:cNvSpPr/>
+            <p:nvPr/>
+          </p:nvSpPr>
+          <p:spPr>
+            <a:xfrm>
+              <a:off x="8096097" y="2419258"/>
+              <a:ext cx="683564" cy="2637373"/>
+            </a:xfrm>
+            <a:prstGeom prst="rect">
+              <a:avLst/>
+            </a:prstGeom>
+            <a:solidFill>
+              <a:srgbClr val="8E9AAF"/>
+            </a:solidFill>
+            <a:ln>
+              <a:noFill/>
+            </a:ln>
+            <a:effectLst/>
+          </p:spPr>
+          <p:style>
+            <a:lnRef idx="1">
+              <a:schemeClr val="accent1"/>
+            </a:lnRef>
+            <a:fillRef idx="3">
+              <a:schemeClr val="accent1"/>
+            </a:fillRef>
+            <a:effectRef idx="2">
+              <a:schemeClr val="accent1"/>
+            </a:effectRef>
+            <a:fontRef idx="minor">
+              <a:schemeClr val="lt1"/>
+            </a:fontRef>
+          </p:style>
+          <p:txBody>
+            <a:bodyPr rtlCol="0" anchor="ctr"/>
+            <a:lstStyle/>
+            <a:p/>
+          </p:txBody>
+        </p:sp>
+        <p:sp>
+          <p:nvSpPr>
+            <p:cNvPr id="24" name="TextBox 23"/>
+            <p:cNvSpPr txBox="1"/>
+            <p:nvPr/>
+          </p:nvSpPr>
+          <p:spPr>
+            <a:xfrm>
+              <a:off x="7848599" y="2090074"/>
+              <a:ext cx="1178559" cy="292608"/>
+            </a:xfrm>
+            <a:prstGeom prst="rect">
+              <a:avLst/>
+            </a:prstGeom>
+            <a:noFill/>
+          </p:spPr>
+          <p:txBody>
+            <a:bodyPr wrap="square" anchor="t" lIns="36576" rIns="36576" tIns="18288" bIns="18288">
+              <a:spAutoFit/>
+            </a:bodyPr>
+            <a:lstStyle/>
+            <a:p>
+              <a:pPr algn="ctr">
+                <a:spcAft>
+                  <a:spcPts val="0"/>
+                </a:spcAft>
+              </a:pPr>
+              <a:r>
+                <a:rPr sz="1300" b="1">
+                  <a:solidFill>
+                    <a:srgbClr val="1E1E1E"/>
+                  </a:solidFill>
+                  <a:latin typeface="Calibri"/>
+                </a:rPr>
+                <a:t>0.640</a:t>
+              </a:r>
+            </a:p>
+          </p:txBody>
+        </p:sp>
+        <p:sp>
+          <p:nvSpPr>
+            <p:cNvPr id="25" name="TextBox 24"/>
+            <p:cNvSpPr txBox="1"/>
+            <p:nvPr/>
+          </p:nvSpPr>
+          <p:spPr>
+            <a:xfrm>
+              <a:off x="7848599" y="5111495"/>
+              <a:ext cx="1178559" cy="566928"/>
+            </a:xfrm>
+            <a:prstGeom prst="rect">
+              <a:avLst/>
+            </a:prstGeom>
+            <a:noFill/>
+          </p:spPr>
+          <p:txBody>
+            <a:bodyPr wrap="square" anchor="t" lIns="36576" rIns="36576" tIns="18288" bIns="18288">
+              <a:spAutoFit/>
+            </a:bodyPr>
+            <a:lstStyle/>
+            <a:p>
+              <a:pPr algn="ctr">
+                <a:spcAft>
+                  <a:spcPts val="0"/>
+                </a:spcAft>
+              </a:pPr>
+              <a:r>
+                <a:rPr sz="1200" b="0">
+                  <a:solidFill>
+                    <a:srgbClr val="1E1E1E"/>
+                  </a:solidFill>
+                  <a:latin typeface="Calibri"/>
+                </a:rPr>
+                <a:t>Swin-UNETR</a:t>
+              </a:r>
+            </a:p>
+            <a:p>
+              <a:pPr algn="ctr">
+                <a:spcAft>
+                  <a:spcPts val="0"/>
+                </a:spcAft>
+              </a:pPr>
+              <a:r>
+                <a:rPr sz="1200" b="0">
+                  <a:solidFill>
+                    <a:srgbClr val="1E1E1E"/>
+                  </a:solidFill>
+                  <a:latin typeface="Calibri"/>
+                </a:rPr>
+                <a:t>(2024)</a:t>
+              </a:r>
+            </a:p>
+          </p:txBody>
+        </p:sp>
+        <p:sp>
+          <p:nvSpPr>
+            <p:cNvPr id="26" name="Rectangle 25"/>
+            <p:cNvSpPr/>
+            <p:nvPr/>
+          </p:nvSpPr>
+          <p:spPr>
+            <a:xfrm>
+              <a:off x="9274657" y="2345082"/>
+              <a:ext cx="683564" cy="2711549"/>
+            </a:xfrm>
+            <a:prstGeom prst="rect">
+              <a:avLst/>
+            </a:prstGeom>
+            <a:solidFill>
+              <a:srgbClr val="E31837"/>
+            </a:solidFill>
+            <a:ln>
+              <a:noFill/>
+            </a:ln>
+            <a:effectLst/>
+          </p:spPr>
+          <p:style>
+            <a:lnRef idx="1">
+              <a:schemeClr val="accent1"/>
+            </a:lnRef>
+            <a:fillRef idx="3">
+              <a:schemeClr val="accent1"/>
+            </a:fillRef>
+            <a:effectRef idx="2">
+              <a:schemeClr val="accent1"/>
+            </a:effectRef>
+            <a:fontRef idx="minor">
+              <a:schemeClr val="lt1"/>
+            </a:fontRef>
+          </p:style>
+          <p:txBody>
+            <a:bodyPr rtlCol="0" anchor="ctr"/>
+            <a:lstStyle/>
+            <a:p/>
+          </p:txBody>
+        </p:sp>
+        <p:sp>
+          <p:nvSpPr>
+            <p:cNvPr id="27" name="TextBox 26"/>
+            <p:cNvSpPr txBox="1"/>
+            <p:nvPr/>
+          </p:nvSpPr>
+          <p:spPr>
+            <a:xfrm>
+              <a:off x="9027160" y="2015898"/>
+              <a:ext cx="1178559" cy="292608"/>
+            </a:xfrm>
+            <a:prstGeom prst="rect">
+              <a:avLst/>
+            </a:prstGeom>
+            <a:noFill/>
+          </p:spPr>
+          <p:txBody>
+            <a:bodyPr wrap="square" anchor="t" lIns="36576" rIns="36576" tIns="18288" bIns="18288">
+              <a:spAutoFit/>
+            </a:bodyPr>
+            <a:lstStyle/>
+            <a:p>
+              <a:pPr algn="ctr">
+                <a:spcAft>
+                  <a:spcPts val="0"/>
+                </a:spcAft>
+              </a:pPr>
+              <a:r>
+                <a:rPr sz="1300" b="1">
                   <a:solidFill>
                     <a:srgbClr val="E31837"/>
                   </a:solidFill>
@@ -22431,14 +22703,14 @@
         </p:sp>
         <p:sp>
           <p:nvSpPr>
-            <p:cNvPr id="22" name="TextBox 21"/>
+            <p:cNvPr id="28" name="TextBox 27"/>
             <p:cNvSpPr txBox="1"/>
             <p:nvPr/>
           </p:nvSpPr>
           <p:spPr>
             <a:xfrm>
-              <a:off x="8353697" y="5111495"/>
-              <a:ext cx="1515291" cy="566928"/>
+              <a:off x="9027160" y="5111495"/>
+              <a:ext cx="1178559" cy="566928"/>
             </a:xfrm>
             <a:prstGeom prst="rect">
               <a:avLst/>
@@ -22486,14 +22758,14 @@
         </p:sp>
         <p:sp>
           <p:nvSpPr>
-            <p:cNvPr id="23" name="Rectangle 22"/>
+            <p:cNvPr id="29" name="Rectangle 28"/>
             <p:cNvSpPr/>
             <p:nvPr/>
           </p:nvSpPr>
           <p:spPr>
             <a:xfrm>
-              <a:off x="10187199" y="2336840"/>
-              <a:ext cx="878869" cy="2719791"/>
+              <a:off x="10453217" y="2336840"/>
+              <a:ext cx="683564" cy="2719791"/>
             </a:xfrm>
             <a:prstGeom prst="rect">
               <a:avLst/>
@@ -22528,14 +22800,14 @@
         </p:sp>
         <p:sp>
           <p:nvSpPr>
-            <p:cNvPr id="24" name="TextBox 23"/>
+            <p:cNvPr id="30" name="TextBox 29"/>
             <p:cNvSpPr txBox="1"/>
             <p:nvPr/>
           </p:nvSpPr>
           <p:spPr>
             <a:xfrm>
-              <a:off x="9868988" y="2007656"/>
-              <a:ext cx="1515291" cy="292608"/>
+              <a:off x="10205719" y="2007656"/>
+              <a:ext cx="1178559" cy="292608"/>
             </a:xfrm>
             <a:prstGeom prst="rect">
               <a:avLst/>
@@ -22554,7 +22826,7 @@
                 </a:spcAft>
               </a:pPr>
               <a:r>
-                <a:rPr sz="1400" b="1">
+                <a:rPr sz="1300" b="1">
                   <a:solidFill>
                     <a:srgbClr val="E31837"/>
                   </a:solidFill>
@@ -22567,14 +22839,14 @@
         </p:sp>
         <p:sp>
           <p:nvSpPr>
-            <p:cNvPr id="25" name="TextBox 24"/>
+            <p:cNvPr id="31" name="TextBox 30"/>
             <p:cNvSpPr txBox="1"/>
             <p:nvPr/>
           </p:nvSpPr>
           <p:spPr>
             <a:xfrm>
-              <a:off x="9868988" y="5111495"/>
-              <a:ext cx="1515291" cy="566928"/>
+              <a:off x="10205719" y="5111495"/>
+              <a:ext cx="1178559" cy="566928"/>
             </a:xfrm>
             <a:prstGeom prst="rect">
               <a:avLst/>
@@ -22623,14 +22895,14 @@
       </p:grpSp>
       <p:sp>
         <p:nvSpPr>
-          <p:cNvPr id="26" name="TextBox 25"/>
+          <p:cNvPr id="32" name="TextBox 31"/>
           <p:cNvSpPr txBox="1"/>
           <p:nvPr/>
         </p:nvSpPr>
         <p:spPr>
           <a:xfrm>
-            <a:off x="777240" y="5715000"/>
-            <a:ext cx="10607040" cy="548640"/>
+            <a:off x="777240" y="5650992"/>
+            <a:ext cx="10607040" cy="685800"/>
           </a:xfrm>
           <a:prstGeom prst="rect">
             <a:avLst/>
@@ -22645,7 +22917,7 @@
           <a:p>
             <a:pPr algn="l">
               <a:spcAft>
-                <a:spcPts val="600"/>
+                <a:spcPts val="200"/>
               </a:spcAft>
             </a:pPr>
             <a:r>
@@ -22655,7 +22927,7 @@
                 </a:solidFill>
                 <a:latin typeface="Calibri"/>
               </a:rPr>
-              <a:t>max F1 on the 109 expert-labelled LOFAR images. </a:t>
+              <a:t>max F1 on the 109 expert-labelled LOFAR images; every network was trained on AOFlagger labels. </a:t>
             </a:r>
             <a:r>
               <a:rPr sz="1200" b="0">
@@ -22664,7 +22936,23 @@
                 </a:solidFill>
                 <a:latin typeface="Calibri"/>
               </a:rPr>
-              <a:t>Mesarcik et al. U-Net and RFI-Net values as published by Mesarcik et al. (2022).</a:t>
+              <a:t>Mesarcik U-Net, RFI-Net: Mesarcik et al. (2022); RFDL: van Zyl &amp; Grobler (2024); Swin-UNETR (400M parameters): Ouyang et al. (2024).</a:t>
+            </a:r>
+          </a:p>
+          <a:p>
+            <a:pPr algn="l">
+              <a:spcAft>
+                <a:spcPts val="200"/>
+              </a:spcAft>
+            </a:pPr>
+            <a:r>
+              <a:rPr sz="1200" b="1">
+                <a:solidFill>
+                  <a:srgbClr val="0F2043"/>
+                </a:solidFill>
+                <a:latin typeface="Calibri"/>
+              </a:rPr>
+              <a:t>Our lead over RFDL and Swin-UNETR (about 0.02) is smaller than the test-set uncertainty (±0.04).</a:t>
             </a:r>
           </a:p>
         </p:txBody>
@@ -22757,7 +23045,7 @@
                 </a:solidFill>
                 <a:latin typeface="Calibri"/>
               </a:rPr>
-              <a:t>test changes 4–9 one at a time, starting with the Dice loss.</a:t>
+              <a:t>test changes 5, 6, 7 and 9 one at a time, starting with the Dice loss.</a:t>
             </a:r>
           </a:p>
           <a:p>
@@ -23168,7 +23456,7 @@
                 </a:solidFill>
                 <a:latin typeface="Calibri"/>
               </a:rPr>
-              <a:t>0.660 — highest of all methods</a:t>
+              <a:t>0.660 — highest we found (best published: 0.640)</a:t>
             </a:r>
           </a:p>
           <a:p>
@@ -24307,7 +24595,7 @@
                           </a:solidFill>
                           <a:latin typeface="Calibri"/>
                         </a:rPr>
-                        <a:t>Max-pooling (3 levels)</a:t>
+                        <a:t>Max-pooling, 2 times (3 levels)</a:t>
                       </a:r>
                     </a:p>
                   </a:txBody>
@@ -24330,7 +24618,7 @@
                           </a:solidFill>
                           <a:latin typeface="Calibri"/>
                         </a:rPr>
-                        <a:t>Stride-2 convolutions (5 levels)</a:t>
+                        <a:t>Stride-2 convolutions, 5 times</a:t>
                       </a:r>
                     </a:p>
                   </a:txBody>
@@ -24956,7 +25244,7 @@
                 </a:solidFill>
                 <a:latin typeface="Calibri"/>
               </a:rPr>
-              <a:t>•  A strip filter looks along a long thin line instead (7, 11 or 21 pixels).</a:t>
+              <a:t>•  Each strip path chains a 1×K and a K×1 filter (K = 7, 11, 21): together they cover a K×K square.</a:t>
             </a:r>
           </a:p>
           <a:p>
@@ -24972,7 +25260,7 @@
                 </a:solidFill>
                 <a:latin typeface="Calibri"/>
               </a:rPr>
-              <a:t>•  Idea: RFI often appears as long streaks, so this should catch faint ones.</a:t>
+              <a:t>•  Idea: RFI appears as long streaks. As built, it looks at a wider area, not a thin line.</a:t>
             </a:r>
           </a:p>
         </p:txBody>
@@ -25553,7 +25841,7 @@
                 </a:solidFill>
                 <a:latin typeface="Calibri"/>
               </a:rPr>
-              <a:t>•  GroupNorm rescales them after every layer so they stay in a steady range.</a:t>
+              <a:t>•  GroupNorm rescales them inside every block so they stay in a steady range.</a:t>
             </a:r>
           </a:p>
           <a:p>
@@ -26334,7 +26622,7 @@
                 </a:solidFill>
                 <a:latin typeface="Calibri"/>
               </a:rPr>
-              <a:t>•  Here it pushed the model to over-predict RFI and hurt its final decisions.</a:t>
+              <a:t>•  Our earlier version used it; removing it improved every run (0.647 → 0.660).</a:t>
             </a:r>
           </a:p>
           <a:p>
@@ -26350,7 +26638,7 @@
                 </a:solidFill>
                 <a:latin typeface="Calibri"/>
               </a:rPr>
-              <a:t>•  Removing it improved the score in every run (0.647 → 0.660).</a:t>
+              <a:t>•  tf_unet does not use it either, so this is not a difference from tf_unet.</a:t>
             </a:r>
           </a:p>
         </p:txBody>
@@ -26502,7 +26790,7 @@
                 </a:solidFill>
                 <a:latin typeface="Calibri"/>
               </a:rPr>
-              <a:t>•  4 levels deep instead of 3, but thinner: 8 filters in the first layer, not 32.</a:t>
+              <a:t>•  Shrinks the image 4 times instead of 2, but thinner: 8 filters in the first layer, not 32.</a:t>
             </a:r>
           </a:p>
           <a:p>
@@ -29037,7 +29325,7 @@
                   </a:solidFill>
                   <a:latin typeface="Calibri"/>
                 </a:rPr>
-                <a:t>normal filter</a:t>
+                <a:t>normal 3×3 filter</a:t>
               </a:r>
             </a:p>
           </p:txBody>
@@ -29057,7 +29345,7 @@
               <a:avLst/>
             </a:prstGeom>
             <a:solidFill>
-              <a:srgbClr val="FFFFFF"/>
+              <a:srgbClr val="E31837"/>
             </a:solidFill>
             <a:ln w="6350">
               <a:solidFill>
@@ -29101,7 +29389,7 @@
               <a:avLst/>
             </a:prstGeom>
             <a:solidFill>
-              <a:srgbClr val="FFFFFF"/>
+              <a:srgbClr val="E31837"/>
             </a:solidFill>
             <a:ln w="6350">
               <a:solidFill>
@@ -29145,7 +29433,7 @@
               <a:avLst/>
             </a:prstGeom>
             <a:solidFill>
-              <a:srgbClr val="FFFFFF"/>
+              <a:srgbClr val="E31837"/>
             </a:solidFill>
             <a:ln w="6350">
               <a:solidFill>
@@ -29189,7 +29477,7 @@
               <a:avLst/>
             </a:prstGeom>
             <a:solidFill>
-              <a:srgbClr val="FFFFFF"/>
+              <a:srgbClr val="E31837"/>
             </a:solidFill>
             <a:ln w="6350">
               <a:solidFill>
@@ -29233,7 +29521,7 @@
               <a:avLst/>
             </a:prstGeom>
             <a:solidFill>
-              <a:srgbClr val="FFFFFF"/>
+              <a:srgbClr val="E31837"/>
             </a:solidFill>
             <a:ln w="6350">
               <a:solidFill>
@@ -29277,7 +29565,7 @@
               <a:avLst/>
             </a:prstGeom>
             <a:solidFill>
-              <a:srgbClr val="FFFFFF"/>
+              <a:srgbClr val="E31837"/>
             </a:solidFill>
             <a:ln w="6350">
               <a:solidFill>
@@ -29321,7 +29609,7 @@
               <a:avLst/>
             </a:prstGeom>
             <a:solidFill>
-              <a:srgbClr val="FFFFFF"/>
+              <a:srgbClr val="E31837"/>
             </a:solidFill>
             <a:ln w="6350">
               <a:solidFill>
@@ -29365,7 +29653,7 @@
               <a:avLst/>
             </a:prstGeom>
             <a:solidFill>
-              <a:srgbClr val="FFFFFF"/>
+              <a:srgbClr val="E31837"/>
             </a:solidFill>
             <a:ln w="6350">
               <a:solidFill>
@@ -29409,7 +29697,7 @@
               <a:avLst/>
             </a:prstGeom>
             <a:solidFill>
-              <a:srgbClr val="FFFFFF"/>
+              <a:srgbClr val="E31837"/>
             </a:solidFill>
             <a:ln w="6350">
               <a:solidFill>
@@ -29453,7 +29741,7 @@
               <a:avLst/>
             </a:prstGeom>
             <a:solidFill>
-              <a:srgbClr val="FFFFFF"/>
+              <a:srgbClr val="E31837"/>
             </a:solidFill>
             <a:ln w="6350">
               <a:solidFill>
@@ -29497,7 +29785,7 @@
               <a:avLst/>
             </a:prstGeom>
             <a:solidFill>
-              <a:srgbClr val="FFFFFF"/>
+              <a:srgbClr val="E31837"/>
             </a:solidFill>
             <a:ln w="6350">
               <a:solidFill>
@@ -29541,7 +29829,7 @@
               <a:avLst/>
             </a:prstGeom>
             <a:solidFill>
-              <a:srgbClr val="FFFFFF"/>
+              <a:srgbClr val="E31837"/>
             </a:solidFill>
             <a:ln w="6350">
               <a:solidFill>
@@ -29585,7 +29873,7 @@
               <a:avLst/>
             </a:prstGeom>
             <a:solidFill>
-              <a:srgbClr val="FFFFFF"/>
+              <a:srgbClr val="E31837"/>
             </a:solidFill>
             <a:ln w="6350">
               <a:solidFill>
@@ -29629,7 +29917,7 @@
               <a:avLst/>
             </a:prstGeom>
             <a:solidFill>
-              <a:srgbClr val="FFFFFF"/>
+              <a:srgbClr val="E31837"/>
             </a:solidFill>
             <a:ln w="6350">
               <a:solidFill>
@@ -29673,7 +29961,7 @@
               <a:avLst/>
             </a:prstGeom>
             <a:solidFill>
-              <a:srgbClr val="FFFFFF"/>
+              <a:srgbClr val="E31837"/>
             </a:solidFill>
             <a:ln w="6350">
               <a:solidFill>
@@ -29717,7 +30005,7 @@
               <a:avLst/>
             </a:prstGeom>
             <a:solidFill>
-              <a:srgbClr val="FFFFFF"/>
+              <a:srgbClr val="E31837"/>
             </a:solidFill>
             <a:ln w="6350">
               <a:solidFill>
@@ -29761,7 +30049,7 @@
               <a:avLst/>
             </a:prstGeom>
             <a:solidFill>
-              <a:srgbClr val="FFFFFF"/>
+              <a:srgbClr val="E31837"/>
             </a:solidFill>
             <a:ln w="6350">
               <a:solidFill>
@@ -29805,7 +30093,7 @@
               <a:avLst/>
             </a:prstGeom>
             <a:solidFill>
-              <a:srgbClr val="FFFFFF"/>
+              <a:srgbClr val="E31837"/>
             </a:solidFill>
             <a:ln w="6350">
               <a:solidFill>
@@ -29849,7 +30137,7 @@
               <a:avLst/>
             </a:prstGeom>
             <a:solidFill>
-              <a:srgbClr val="FFFFFF"/>
+              <a:srgbClr val="E31837"/>
             </a:solidFill>
             <a:ln w="6350">
               <a:solidFill>
@@ -29893,7 +30181,7 @@
               <a:avLst/>
             </a:prstGeom>
             <a:solidFill>
-              <a:srgbClr val="FFFFFF"/>
+              <a:srgbClr val="E31837"/>
             </a:solidFill>
             <a:ln w="6350">
               <a:solidFill>
@@ -29937,7 +30225,7 @@
               <a:avLst/>
             </a:prstGeom>
             <a:solidFill>
-              <a:srgbClr val="FFFFFF"/>
+              <a:srgbClr val="E31837"/>
             </a:solidFill>
             <a:ln w="6350">
               <a:solidFill>
@@ -30289,7 +30577,7 @@
               <a:avLst/>
             </a:prstGeom>
             <a:solidFill>
-              <a:srgbClr val="FFFFFF"/>
+              <a:srgbClr val="E31837"/>
             </a:solidFill>
             <a:ln w="6350">
               <a:solidFill>
@@ -30333,7 +30621,7 @@
               <a:avLst/>
             </a:prstGeom>
             <a:solidFill>
-              <a:srgbClr val="FFFFFF"/>
+              <a:srgbClr val="E31837"/>
             </a:solidFill>
             <a:ln w="6350">
               <a:solidFill>
@@ -30377,7 +30665,7 @@
               <a:avLst/>
             </a:prstGeom>
             <a:solidFill>
-              <a:srgbClr val="FFFFFF"/>
+              <a:srgbClr val="E31837"/>
             </a:solidFill>
             <a:ln w="6350">
               <a:solidFill>
@@ -30421,7 +30709,7 @@
               <a:avLst/>
             </a:prstGeom>
             <a:solidFill>
-              <a:srgbClr val="FFFFFF"/>
+              <a:srgbClr val="E31837"/>
             </a:solidFill>
             <a:ln w="6350">
               <a:solidFill>
@@ -30465,7 +30753,7 @@
               <a:avLst/>
             </a:prstGeom>
             <a:solidFill>
-              <a:srgbClr val="FFFFFF"/>
+              <a:srgbClr val="E31837"/>
             </a:solidFill>
             <a:ln w="6350">
               <a:solidFill>
@@ -30509,7 +30797,7 @@
               <a:avLst/>
             </a:prstGeom>
             <a:solidFill>
-              <a:srgbClr val="FFFFFF"/>
+              <a:srgbClr val="E31837"/>
             </a:solidFill>
             <a:ln w="6350">
               <a:solidFill>
@@ -30553,7 +30841,7 @@
               <a:avLst/>
             </a:prstGeom>
             <a:solidFill>
-              <a:srgbClr val="FFFFFF"/>
+              <a:srgbClr val="E31837"/>
             </a:solidFill>
             <a:ln w="6350">
               <a:solidFill>
@@ -30597,7 +30885,7 @@
               <a:avLst/>
             </a:prstGeom>
             <a:solidFill>
-              <a:srgbClr val="FFFFFF"/>
+              <a:srgbClr val="E31837"/>
             </a:solidFill>
             <a:ln w="6350">
               <a:solidFill>
@@ -30641,7 +30929,7 @@
               <a:avLst/>
             </a:prstGeom>
             <a:solidFill>
-              <a:srgbClr val="FFFFFF"/>
+              <a:srgbClr val="E31837"/>
             </a:solidFill>
             <a:ln w="6350">
               <a:solidFill>
@@ -30685,7 +30973,7 @@
               <a:avLst/>
             </a:prstGeom>
             <a:solidFill>
-              <a:srgbClr val="FFFFFF"/>
+              <a:srgbClr val="E31837"/>
             </a:solidFill>
             <a:ln w="6350">
               <a:solidFill>
@@ -30729,7 +31017,7 @@
               <a:avLst/>
             </a:prstGeom>
             <a:solidFill>
-              <a:srgbClr val="FFFFFF"/>
+              <a:srgbClr val="E31837"/>
             </a:solidFill>
             <a:ln w="6350">
               <a:solidFill>
@@ -30773,7 +31061,7 @@
               <a:avLst/>
             </a:prstGeom>
             <a:solidFill>
-              <a:srgbClr val="FFFFFF"/>
+              <a:srgbClr val="E31837"/>
             </a:solidFill>
             <a:ln w="6350">
               <a:solidFill>
@@ -30817,7 +31105,7 @@
               <a:avLst/>
             </a:prstGeom>
             <a:solidFill>
-              <a:srgbClr val="FFFFFF"/>
+              <a:srgbClr val="E31837"/>
             </a:solidFill>
             <a:ln w="6350">
               <a:solidFill>
@@ -30861,7 +31149,7 @@
               <a:avLst/>
             </a:prstGeom>
             <a:solidFill>
-              <a:srgbClr val="FFFFFF"/>
+              <a:srgbClr val="E31837"/>
             </a:solidFill>
             <a:ln w="6350">
               <a:solidFill>
@@ -30905,7 +31193,7 @@
               <a:avLst/>
             </a:prstGeom>
             <a:solidFill>
-              <a:srgbClr val="FFFFFF"/>
+              <a:srgbClr val="E31837"/>
             </a:solidFill>
             <a:ln w="6350">
               <a:solidFill>
@@ -30949,7 +31237,7 @@
               <a:avLst/>
             </a:prstGeom>
             <a:solidFill>
-              <a:srgbClr val="FFFFFF"/>
+              <a:srgbClr val="E31837"/>
             </a:solidFill>
             <a:ln w="6350">
               <a:solidFill>
@@ -30993,7 +31281,7 @@
               <a:avLst/>
             </a:prstGeom>
             <a:solidFill>
-              <a:srgbClr val="FFFFFF"/>
+              <a:srgbClr val="E31837"/>
             </a:solidFill>
             <a:ln w="6350">
               <a:solidFill>
@@ -31037,7 +31325,7 @@
               <a:avLst/>
             </a:prstGeom>
             <a:solidFill>
-              <a:srgbClr val="FFFFFF"/>
+              <a:srgbClr val="E31837"/>
             </a:solidFill>
             <a:ln w="6350">
               <a:solidFill>
@@ -31081,7 +31369,7 @@
               <a:avLst/>
             </a:prstGeom>
             <a:solidFill>
-              <a:srgbClr val="FFFFFF"/>
+              <a:srgbClr val="E31837"/>
             </a:solidFill>
             <a:ln w="6350">
               <a:solidFill>
@@ -31125,7 +31413,7 @@
               <a:avLst/>
             </a:prstGeom>
             <a:solidFill>
-              <a:srgbClr val="FFFFFF"/>
+              <a:srgbClr val="E31837"/>
             </a:solidFill>
             <a:ln w="6350">
               <a:solidFill>
@@ -31169,7 +31457,7 @@
               <a:avLst/>
             </a:prstGeom>
             <a:solidFill>
-              <a:srgbClr val="FFFFFF"/>
+              <a:srgbClr val="E31837"/>
             </a:solidFill>
             <a:ln w="6350">
               <a:solidFill>
@@ -31232,7 +31520,7 @@
                   </a:solidFill>
                   <a:latin typeface="Calibri"/>
                 </a:rPr>
-                <a:t>strip filter</a:t>
+                <a:t>strip path: 1×7 then 7×1</a:t>
               </a:r>
             </a:p>
           </p:txBody>
@@ -32250,7 +32538,7 @@
                 </a:solidFill>
                 <a:latin typeface="Calibri"/>
               </a:rPr>
-              <a:t>Looks along long thin lines (7, 11 or 21 pixels) instead of small squares.</a:t>
+              <a:t>Chains a 1×7 and a 7×1 filter (also 11 and 21). Together they cover a whole square, not a line.</a:t>
             </a:r>
           </a:p>
           <a:p>
@@ -32275,7 +32563,7 @@
                 </a:solidFill>
                 <a:latin typeface="Calibri"/>
               </a:rPr>
-              <a:t>RFI often appears as streaks.</a:t>
+              <a:t>catch streaks. As built, it sees a wider area.</a:t>
             </a:r>
           </a:p>
         </p:txBody>
@@ -33292,7 +33580,7 @@
                 </a:solidFill>
                 <a:latin typeface="Calibri"/>
               </a:rPr>
-              <a:t>Strips, shortcuts and attention add 18% more parameters but no accuracy.</a:t>
+              <a:t>Strips, shortcuts and attention add 22% more parameters but no accuracy.</a:t>
             </a:r>
           </a:p>
         </p:txBody>

</xml_diff>